<commit_message>
Fix ns-3 section in documentation, update slides and ns-3 README
</commit_message>
<xml_diff>
--- a/docs/presentation.pptx
+++ b/docs/presentation.pptx
@@ -3850,7 +3850,7 @@
                 <a:ea typeface="Cambria" pitchFamily="34" charset="-122"/>
                 <a:cs typeface="Cambria" pitchFamily="34" charset="-120"/>
               </a:rPr>
-              <a:t>76</a:t>
+              <a:t>77</a:t>
             </a:r>
             <a:endParaRPr lang="en-US" sz="4800" dirty="0"/>
           </a:p>
@@ -5686,7 +5686,7 @@
                 <a:ea typeface="Calibri" pitchFamily="34" charset="-122"/>
                 <a:cs typeface="Calibri" pitchFamily="34" charset="-120"/>
               </a:rPr>
-              <a:t>Status: bridge tested; EMANE runtime not yet executed</a:t>
+              <a:t>Status: executed in Docker (EMANE 1.5.3); hidden-terminal UDP loss 6-14% vs 30% with a colliding schedule</a:t>
             </a:r>
             <a:endParaRPr lang="en-US" sz="1400" dirty="0"/>
           </a:p>

</xml_diff>